<commit_message>
Real-data results for the extensions and end-to-end training
- Two-stage extensions over 40 windows: PCA/PLS/LDA/persistence-aware reduced
  networks, GMM and size experts, linear and kernel SVR
- E2E for Linear, NN3, Ridge, GMM experts and PCA20-NN3; decision-aware PCA
  (mu = 0.1, 1); NN3 with 20 bps costs; mean-SD E2E at eta = 1; NN3 from scratch
- Faster mean-SD layer: Brent root search with warm starts, days solved in
  parallel, fewer breakpoints when yesterday's weight is zero (835 s -> 139 s
  per window); zeta compared on the 2014 windows only
- Fixes: chunked persistence covariance (out-of-memory crash), E2E daily files
  excluded from load_predictions
- run_real.py / run_chain.sh run the experiments with automatic resume
- report/make_decision.py: each E2E model against its two-stage start, costs
  and mean-SD benchmarks; report, slides and README updated with the results
</commit_message>
<xml_diff>
--- a/report/ML_Markowitz_presentation.pptx
+++ b/report/ML_Markowitz_presentation.pptx
@@ -113,29 +113,29 @@
   <p:extLst>
     <p:ext uri="{521415D9-36F7-43E2-AB2F-B90AF26B5E84}">
       <p14:sectionLst xmlns:p14="http://schemas.microsoft.com/office/powerpoint/2010/main">
-        <p14:section name="Introduction" id="{87413b41-94f9-0d56-d9de-947c256df19a}">
+        <p14:section name="Introduction" id="{f3f42733-604d-3dc9-6955-edd92fbde646}">
           <p14:sldIdLst>
             <p14:sldId id="256"/>
           </p14:sldIdLst>
         </p14:section>
-        <p14:section name="Problem" id="{be76eed5-10fe-2547-900c-47eb5b7b1c9a}">
+        <p14:section name="Problem" id="{7f94e605-d36b-146c-4592-d0352d881994}">
           <p14:sldIdLst>
             <p14:sldId id="257"/>
           </p14:sldIdLst>
         </p14:section>
-        <p14:section name="Methodology" id="{c6adea7b-ebe4-4e3c-30d5-67bb2e5058cb}">
+        <p14:section name="Methodology" id="{a26d28d3-86f9-c9d2-3c2e-742b70aa49c7}">
           <p14:sldIdLst>
             <p14:sldId id="258"/>
             <p14:sldId id="259"/>
           </p14:sldIdLst>
         </p14:section>
-        <p14:section name="Extensions" id="{95450f19-4ca1-4cfe-4bdc-ceb2b87e9649}">
+        <p14:section name="Extensions" id="{c653a87d-25a8-a5bc-120e-6b3d99658bdb}">
           <p14:sldIdLst>
             <p14:sldId id="260"/>
             <p14:sldId id="261"/>
           </p14:sldIdLst>
         </p14:section>
-        <p14:section name="Results" id="{6bcbc3f5-7fd4-822a-f966-4c48ec85c577}">
+        <p14:section name="Results" id="{c200a710-6cfc-ec8e-a964-f606b600a4db}">
           <p14:sldIdLst>
             <p14:sldId id="262"/>
           </p14:sldIdLst>
@@ -175,7 +175,7 @@
                 </a:solidFill>
                 <a:latin typeface="+mn-lt"/>
               </a:rPr>
-              <a:t>Statistical accuracy: mean daily rank IC</a:t>
+              <a:t>Long-only top decile: Sharpe ratio, before costs</a:t>
             </a:r>
           </a:p>
         </c:rich>
@@ -199,7 +199,7 @@
               <c:strCache>
                 <c:ptCount val="1"/>
                 <c:pt idx="0">
-                  <c:v>Rank IC</c:v>
+                  <c:v>Two-stage (MSE)</c:v>
                 </c:pt>
               </c:strCache>
             </c:strRef>
@@ -212,13 +212,13 @@
           </c:spPr>
           <c:invertIfNegative val="0"/>
           <c:dLbls>
-            <c:numFmt formatCode="0.000" sourceLinked="0"/>
+            <c:numFmt formatCode="0.00" sourceLinked="0"/>
             <c:txPr>
               <a:bodyPr/>
               <a:lstStyle/>
               <a:p>
                 <a:pPr>
-                  <a:defRPr b="0" i="0" strike="noStrike" sz="1100" u="none">
+                  <a:defRPr b="0" i="0" strike="noStrike" sz="1000" u="none">
                     <a:solidFill>
                       <a:srgbClr val="52514E"/>
                     </a:solidFill>
@@ -237,47 +237,35 @@
           </c:dLbls>
           <c:cat>
             <c:multiLvlStrRef>
-              <c:f>Sheet1!$A$2:$A$14</c:f>
+              <c:f>Sheet1!$A$2:$A$10</c:f>
               <c:multiLvlStrCache>
-                <c:ptCount val="13"/>
+                <c:ptCount val="9"/>
                 <c:lvl>
                   <c:pt idx="0">
-                    <c:v>LDA-top</c:v>
+                    <c:v>PCA20-Linear, DA μ=1</c:v>
                   </c:pt>
                   <c:pt idx="1">
-                    <c:v>PCR</c:v>
+                    <c:v>PCA20-Linear, DA μ=0.1</c:v>
                   </c:pt>
                   <c:pt idx="2">
-                    <c:v>NN5</c:v>
+                    <c:v>PCA20-NN3, DA μ=1</c:v>
                   </c:pt>
                   <c:pt idx="3">
-                    <c:v>Ridge-rank</c:v>
+                    <c:v>PCA20-NN3, DA μ=0.1</c:v>
                   </c:pt>
                   <c:pt idx="4">
-                    <c:v>LDA</c:v>
+                    <c:v>PCA20-NN3, PCA fixed</c:v>
                   </c:pt>
                   <c:pt idx="5">
+                    <c:v>GMM experts</c:v>
+                  </c:pt>
+                  <c:pt idx="6">
                     <c:v>Ridge</c:v>
                   </c:pt>
-                  <c:pt idx="6">
+                  <c:pt idx="7">
                     <c:v>NN3</c:v>
                   </c:pt>
-                  <c:pt idx="7">
-                    <c:v>NN2</c:v>
-                  </c:pt>
                   <c:pt idx="8">
-                    <c:v>PLS</c:v>
-                  </c:pt>
-                  <c:pt idx="9">
-                    <c:v>NN4</c:v>
-                  </c:pt>
-                  <c:pt idx="10">
-                    <c:v>OLS</c:v>
-                  </c:pt>
-                  <c:pt idx="11">
-                    <c:v>NN1</c:v>
-                  </c:pt>
-                  <c:pt idx="12">
                     <c:v>Linear</c:v>
                   </c:pt>
                 </c:lvl>
@@ -286,61 +274,168 @@
           </c:cat>
           <c:val>
             <c:numRef>
-              <c:f>Sheet1!$B$2:$B$14</c:f>
+              <c:f>Sheet1!$B$2:$B$10</c:f>
               <c:numCache>
                 <c:formatCode>General</c:formatCode>
-                <c:ptCount val="13"/>
+                <c:ptCount val="9"/>
                 <c:pt idx="0">
-                  <c:v>0.061</c:v>
+                  <c:v>1</c:v>
                 </c:pt>
                 <c:pt idx="1">
-                  <c:v>0.065</c:v>
+                  <c:v>1</c:v>
                 </c:pt>
                 <c:pt idx="2">
-                  <c:v>0.06</c:v>
+                  <c:v>1.24</c:v>
                 </c:pt>
                 <c:pt idx="3">
-                  <c:v>0.077</c:v>
+                  <c:v>1.24</c:v>
                 </c:pt>
                 <c:pt idx="4">
-                  <c:v>0.073</c:v>
+                  <c:v>1.24</c:v>
                 </c:pt>
                 <c:pt idx="5">
-                  <c:v>0.069</c:v>
+                  <c:v>1.27</c:v>
                 </c:pt>
                 <c:pt idx="6">
-                  <c:v>0.061</c:v>
+                  <c:v>1.23</c:v>
                 </c:pt>
                 <c:pt idx="7">
-                  <c:v>0.063</c:v>
+                  <c:v>1.23</c:v>
                 </c:pt>
                 <c:pt idx="8">
-                  <c:v>0.071</c:v>
+                  <c:v>1.36</c:v>
                 </c:pt>
-                <c:pt idx="9">
-                  <c:v>0.063</c:v>
+              </c:numCache>
+            </c:numRef>
+          </c:val>
+        </c:ser>
+        <c:ser>
+          <c:idx val="1"/>
+          <c:order val="1"/>
+          <c:tx>
+            <c:strRef>
+              <c:f>Sheet1!$C$1</c:f>
+              <c:strCache>
+                <c:ptCount val="1"/>
+                <c:pt idx="0">
+                  <c:v>End-to-end</c:v>
                 </c:pt>
-                <c:pt idx="10">
-                  <c:v>0.066</c:v>
+              </c:strCache>
+            </c:strRef>
+          </c:tx>
+          <c:spPr>
+            <a:solidFill>
+              <a:srgbClr val="EB6834"/>
+            </a:solidFill>
+            <a:effectLst/>
+          </c:spPr>
+          <c:invertIfNegative val="0"/>
+          <c:dLbls>
+            <c:numFmt formatCode="0.00" sourceLinked="0"/>
+            <c:txPr>
+              <a:bodyPr/>
+              <a:lstStyle/>
+              <a:p>
+                <a:pPr>
+                  <a:defRPr b="0" i="0" strike="noStrike" sz="1000" u="none">
+                    <a:solidFill>
+                      <a:srgbClr val="52514E"/>
+                    </a:solidFill>
+                    <a:latin typeface="+mn-lt"/>
+                  </a:defRPr>
+                </a:pPr>
+              </a:p>
+            </c:txPr>
+            <c:showLegendKey val="0"/>
+            <c:showVal val="1"/>
+            <c:showCatName val="0"/>
+            <c:showSerName val="0"/>
+            <c:showPercent val="0"/>
+            <c:showBubbleSize val="0"/>
+            <c:showLeaderLines val="0"/>
+          </c:dLbls>
+          <c:cat>
+            <c:multiLvlStrRef>
+              <c:f>Sheet1!$A$2:$A$10</c:f>
+              <c:multiLvlStrCache>
+                <c:ptCount val="9"/>
+                <c:lvl>
+                  <c:pt idx="0">
+                    <c:v>PCA20-Linear, DA μ=1</c:v>
+                  </c:pt>
+                  <c:pt idx="1">
+                    <c:v>PCA20-Linear, DA μ=0.1</c:v>
+                  </c:pt>
+                  <c:pt idx="2">
+                    <c:v>PCA20-NN3, DA μ=1</c:v>
+                  </c:pt>
+                  <c:pt idx="3">
+                    <c:v>PCA20-NN3, DA μ=0.1</c:v>
+                  </c:pt>
+                  <c:pt idx="4">
+                    <c:v>PCA20-NN3, PCA fixed</c:v>
+                  </c:pt>
+                  <c:pt idx="5">
+                    <c:v>GMM experts</c:v>
+                  </c:pt>
+                  <c:pt idx="6">
+                    <c:v>Ridge</c:v>
+                  </c:pt>
+                  <c:pt idx="7">
+                    <c:v>NN3</c:v>
+                  </c:pt>
+                  <c:pt idx="8">
+                    <c:v>Linear</c:v>
+                  </c:pt>
+                </c:lvl>
+              </c:multiLvlStrCache>
+            </c:multiLvlStrRef>
+          </c:cat>
+          <c:val>
+            <c:numRef>
+              <c:f>Sheet1!$C$2:$C$10</c:f>
+              <c:numCache>
+                <c:formatCode>General</c:formatCode>
+                <c:ptCount val="9"/>
+                <c:pt idx="0">
+                  <c:v>1.29</c:v>
                 </c:pt>
-                <c:pt idx="11">
-                  <c:v>0.062</c:v>
+                <c:pt idx="1">
+                  <c:v>1.36</c:v>
                 </c:pt>
-                <c:pt idx="12">
-                  <c:v>0.067</c:v>
+                <c:pt idx="2">
+                  <c:v>1.23</c:v>
+                </c:pt>
+                <c:pt idx="3">
+                  <c:v>1.32</c:v>
+                </c:pt>
+                <c:pt idx="4">
+                  <c:v>1.3</c:v>
+                </c:pt>
+                <c:pt idx="5">
+                  <c:v>1.19</c:v>
+                </c:pt>
+                <c:pt idx="6">
+                  <c:v>1.36</c:v>
+                </c:pt>
+                <c:pt idx="7">
+                  <c:v>1.35</c:v>
+                </c:pt>
+                <c:pt idx="8">
+                  <c:v>1.37</c:v>
                 </c:pt>
               </c:numCache>
             </c:numRef>
           </c:val>
         </c:ser>
         <c:dLbls>
-          <c:numFmt formatCode="0.000" sourceLinked="0"/>
+          <c:numFmt formatCode="0.00" sourceLinked="0"/>
           <c:txPr>
             <a:bodyPr/>
             <a:lstStyle/>
             <a:p>
               <a:pPr>
-                <a:defRPr b="0" i="0" strike="noStrike" sz="1100" u="none">
+                <a:defRPr b="0" i="0" strike="noStrike" sz="1000" u="none">
                   <a:solidFill>
                     <a:srgbClr val="52514E"/>
                   </a:solidFill>
@@ -357,7 +452,7 @@
           <c:showBubbleSize val="0"/>
           <c:showLeaderLines val="0"/>
         </c:dLbls>
-        <c:gapWidth val="45"/>
+        <c:gapWidth val="40"/>
         <c:overlap val="0"/>
         <c:axId val="2094734554"/>
         <c:axId val="2094734552"/>
@@ -449,322 +544,26 @@
         <a:effectLst/>
       </c:spPr>
     </c:plotArea>
-    <c:plotVisOnly val="1"/>
-    <c:dispBlanksAs val="span"/>
-  </c:chart>
-  <c:spPr>
-    <a:noFill/>
-    <a:ln>
-      <a:noFill/>
-    </a:ln>
-    <a:effectLst/>
-  </c:spPr>
-  <c:externalData r:id="rId1">
-    <c:autoUpdate val="0"/>
-  </c:externalData>
-</c:chartSpace>
-</file>
-
-<file path=ppt/charts/chart2.xml><?xml version="1.0" encoding="utf-8"?>
-<c:chartSpace xmlns:c="http://schemas.openxmlformats.org/drawingml/2006/chart" xmlns:a="http://schemas.openxmlformats.org/drawingml/2006/main" xmlns:r="http://schemas.openxmlformats.org/officeDocument/2006/relationships">
-  <c:date1904 val="0"/>
-  <c:roundedCorners val="1"/>
-  <c:chart>
-    <c:title>
-      <c:tx>
-        <c:rich>
-          <a:bodyPr/>
-          <a:lstStyle/>
-          <a:p>
-            <a:pPr>
-              <a:defRPr sz="1400" b="0" i="0" u="none" strike="noStrike">
-                <a:solidFill>
-                  <a:srgbClr val="1F2A44"/>
-                </a:solidFill>
-                <a:latin typeface="+mn-lt"/>
-              </a:defRPr>
-            </a:pPr>
-            <a:r>
-              <a:rPr sz="1400" b="0" i="0" u="none" strike="noStrike">
-                <a:solidFill>
-                  <a:srgbClr val="1F2A44"/>
-                </a:solidFill>
-                <a:latin typeface="+mn-lt"/>
-              </a:rPr>
-              <a:t>Portfolio quality: top-decile Sharpe</a:t>
-            </a:r>
-          </a:p>
-        </c:rich>
-      </c:tx>
-      <c:layout/>
+    <c:legend>
+      <c:legendPos val="t"/>
       <c:overlay val="0"/>
-    </c:title>
-    <c:autoTitleDeleted val="0"/>
-    <c:plotArea>
-      <c:layout/>
-      <c:barChart>
-        <c:barDir val="bar"/>
-        <c:grouping val="clustered"/>
-        <c:varyColors val="0"/>
-        <c:ser>
-          <c:idx val="0"/>
-          <c:order val="0"/>
-          <c:tx>
-            <c:strRef>
-              <c:f>Sheet1!$B$1</c:f>
-              <c:strCache>
-                <c:ptCount val="1"/>
-                <c:pt idx="0">
-                  <c:v>Sharpe</c:v>
-                </c:pt>
-              </c:strCache>
-            </c:strRef>
-          </c:tx>
-          <c:spPr>
-            <a:solidFill>
-              <a:srgbClr val="2A78D6"/>
-            </a:solidFill>
-            <a:effectLst/>
-          </c:spPr>
-          <c:invertIfNegative val="0"/>
-          <c:dLbls>
-            <c:numFmt formatCode="0.00" sourceLinked="0"/>
-            <c:txPr>
-              <a:bodyPr/>
-              <a:lstStyle/>
-              <a:p>
-                <a:pPr>
-                  <a:defRPr b="0" i="0" strike="noStrike" sz="1100" u="none">
-                    <a:solidFill>
-                      <a:srgbClr val="52514E"/>
-                    </a:solidFill>
-                    <a:latin typeface="+mn-lt"/>
-                  </a:defRPr>
-                </a:pPr>
-              </a:p>
-            </c:txPr>
-            <c:showLegendKey val="0"/>
-            <c:showVal val="1"/>
-            <c:showCatName val="0"/>
-            <c:showSerName val="0"/>
-            <c:showPercent val="0"/>
-            <c:showBubbleSize val="0"/>
-            <c:showLeaderLines val="0"/>
-          </c:dLbls>
-          <c:cat>
-            <c:multiLvlStrRef>
-              <c:f>Sheet1!$A$2:$A$14</c:f>
-              <c:multiLvlStrCache>
-                <c:ptCount val="13"/>
-                <c:lvl>
-                  <c:pt idx="0">
-                    <c:v>LDA-top</c:v>
-                  </c:pt>
-                  <c:pt idx="1">
-                    <c:v>PCR</c:v>
-                  </c:pt>
-                  <c:pt idx="2">
-                    <c:v>NN5</c:v>
-                  </c:pt>
-                  <c:pt idx="3">
-                    <c:v>Ridge-rank</c:v>
-                  </c:pt>
-                  <c:pt idx="4">
-                    <c:v>LDA</c:v>
-                  </c:pt>
-                  <c:pt idx="5">
-                    <c:v>Ridge</c:v>
-                  </c:pt>
-                  <c:pt idx="6">
-                    <c:v>NN3</c:v>
-                  </c:pt>
-                  <c:pt idx="7">
-                    <c:v>NN2</c:v>
-                  </c:pt>
-                  <c:pt idx="8">
-                    <c:v>PLS</c:v>
-                  </c:pt>
-                  <c:pt idx="9">
-                    <c:v>NN4</c:v>
-                  </c:pt>
-                  <c:pt idx="10">
-                    <c:v>OLS</c:v>
-                  </c:pt>
-                  <c:pt idx="11">
-                    <c:v>NN1</c:v>
-                  </c:pt>
-                  <c:pt idx="12">
-                    <c:v>Linear</c:v>
-                  </c:pt>
-                </c:lvl>
-              </c:multiLvlStrCache>
-            </c:multiLvlStrRef>
-          </c:cat>
-          <c:val>
-            <c:numRef>
-              <c:f>Sheet1!$B$2:$B$14</c:f>
-              <c:numCache>
-                <c:formatCode>General</c:formatCode>
-                <c:ptCount val="13"/>
-                <c:pt idx="0">
-                  <c:v>0.65</c:v>
-                </c:pt>
-                <c:pt idx="1">
-                  <c:v>1.09</c:v>
-                </c:pt>
-                <c:pt idx="2">
-                  <c:v>1.13</c:v>
-                </c:pt>
-                <c:pt idx="3">
-                  <c:v>1.2</c:v>
-                </c:pt>
-                <c:pt idx="4">
-                  <c:v>1.2</c:v>
-                </c:pt>
-                <c:pt idx="5">
-                  <c:v>1.23</c:v>
-                </c:pt>
-                <c:pt idx="6">
-                  <c:v>1.23</c:v>
-                </c:pt>
-                <c:pt idx="7">
-                  <c:v>1.26</c:v>
-                </c:pt>
-                <c:pt idx="8">
-                  <c:v>1.28</c:v>
-                </c:pt>
-                <c:pt idx="9">
-                  <c:v>1.29</c:v>
-                </c:pt>
-                <c:pt idx="10">
-                  <c:v>1.35</c:v>
-                </c:pt>
-                <c:pt idx="11">
-                  <c:v>1.35</c:v>
-                </c:pt>
-                <c:pt idx="12">
-                  <c:v>1.36</c:v>
-                </c:pt>
-              </c:numCache>
-            </c:numRef>
-          </c:val>
-        </c:ser>
-        <c:dLbls>
-          <c:numFmt formatCode="0.00" sourceLinked="0"/>
-          <c:txPr>
-            <a:bodyPr/>
-            <a:lstStyle/>
-            <a:p>
-              <a:pPr>
-                <a:defRPr b="0" i="0" strike="noStrike" sz="1100" u="none">
-                  <a:solidFill>
-                    <a:srgbClr val="52514E"/>
-                  </a:solidFill>
-                  <a:latin typeface="+mn-lt"/>
-                </a:defRPr>
-              </a:pPr>
-            </a:p>
-          </c:txPr>
-          <c:showLegendKey val="0"/>
-          <c:showVal val="1"/>
-          <c:showCatName val="0"/>
-          <c:showSerName val="0"/>
-          <c:showPercent val="0"/>
-          <c:showBubbleSize val="0"/>
-          <c:showLeaderLines val="0"/>
-        </c:dLbls>
-        <c:gapWidth val="45"/>
-        <c:overlap val="0"/>
-        <c:axId val="2094734554"/>
-        <c:axId val="2094734552"/>
-        <c:axId val="2094734556"/>
-      </c:barChart>
-      <c:catAx>
-        <c:axId val="2094734554"/>
-        <c:scaling>
-          <c:orientation val="minMax"/>
-        </c:scaling>
-        <c:delete val="0"/>
-        <c:axPos val="l"/>
-        <c:numFmt formatCode="General" sourceLinked="1"/>
-        <c:majorTickMark val="out"/>
-        <c:minorTickMark val="none"/>
-        <c:tickLblPos val="nextTo"/>
-        <c:spPr>
-          <a:ln w="12700" cap="flat">
-            <a:noFill/>
-            <a:prstDash val="solid"/>
-            <a:round/>
-          </a:ln>
-        </c:spPr>
-        <c:txPr>
-          <a:bodyPr/>
-          <a:lstStyle/>
-          <a:p>
-            <a:pPr>
-              <a:defRPr sz="1100" b="0" i="0" u="none" strike="noStrike">
-                <a:solidFill>
-                  <a:srgbClr val="52514E"/>
-                </a:solidFill>
-                <a:latin typeface="+mn-lt"/>
-              </a:defRPr>
-            </a:pPr>
-            <a:endParaRPr lang="en-US"/>
-          </a:p>
-        </c:txPr>
-        <c:crossAx val="2094734552"/>
-        <c:crosses val="autoZero"/>
-        <c:auto val="1"/>
-        <c:lblAlgn val="ctr"/>
-        <c:noMultiLvlLbl val="1"/>
-      </c:catAx>
-      <c:valAx>
-        <c:axId val="2094734552"/>
-        <c:scaling>
-          <c:orientation val="minMax"/>
-        </c:scaling>
-        <c:delete val="1"/>
-        <c:axPos val="b"/>
-        <c:numFmt formatCode="General" sourceLinked="0"/>
-        <c:majorTickMark val="out"/>
-        <c:minorTickMark val="none"/>
-        <c:tickLblPos val="low"/>
-        <c:spPr>
-          <a:ln w="12700" cap="flat">
-            <a:solidFill>
-              <a:srgbClr val="888888"/>
-            </a:solidFill>
-            <a:prstDash val="solid"/>
-            <a:round/>
-          </a:ln>
-        </c:spPr>
-        <c:txPr>
-          <a:bodyPr/>
-          <a:lstStyle/>
-          <a:p>
-            <a:pPr>
-              <a:defRPr sz="1200" b="0" i="0" u="none" strike="noStrike">
-                <a:solidFill>
-                  <a:srgbClr val="000000"/>
-                </a:solidFill>
-                <a:latin typeface="Arial"/>
-              </a:defRPr>
-            </a:pPr>
-            <a:endParaRPr lang="en-US"/>
-          </a:p>
-        </c:txPr>
-        <c:crossAx val="2094734554"/>
-        <c:crosses val="autoZero"/>
-        <c:crossBetween val="between"/>
-      </c:valAx>
-      <c:spPr>
-        <a:noFill/>
-        <a:ln>
-          <a:noFill/>
-        </a:ln>
-        <a:effectLst/>
-      </c:spPr>
-    </c:plotArea>
+      <c:txPr>
+        <a:bodyPr/>
+        <a:lstStyle/>
+        <a:p>
+          <a:pPr>
+            <a:defRPr sz="1100">
+              <a:solidFill>
+                <a:srgbClr val="52514E"/>
+              </a:solidFill>
+              <a:latin typeface="+mn-lt"/>
+              <a:cs typeface="+mn-lt"/>
+            </a:defRPr>
+          </a:pPr>
+          <a:endParaRPr lang="en-US"/>
+        </a:p>
+      </c:txPr>
+    </c:legend>
     <c:plotVisOnly val="1"/>
     <c:dispBlanksAs val="span"/>
   </c:chart>
@@ -1704,7 +1503,7 @@
           <a:p>
             <a:r>
               <a:rPr lang="en-US" dirty="0"/>
-              <a:t>Long-only, equal-weight top decile, before costs, market-adjusted against the CSI 500. Final E2E and network results are added after training.</a:t>
+              <a:t>Each E2E model is compared with the two-stage model it starts from, on the same test days, before costs. Differences are tested with Newey-West errors. Costs: NN3 trained with 20 bps costs against the MSE top decile and the validation-tuned MSE-Opt. Mean-SD: eta = 1, before costs.</a:t>
             </a:r>
             <a:endParaRPr lang="en-US" dirty="0"/>
           </a:p>
@@ -9119,7 +8918,7 @@
                   <a:schemeClr val="tx1"/>
                 </a:solidFill>
               </a:rPr>
-              <a:t>Results so far (2014–2023, 40 test quarters)</a:t>
+              <a:t>Results: training for the decision (2014–2023)</a:t>
             </a:r>
             <a:endParaRPr lang="en-US" sz="3200" dirty="0"/>
           </a:p>
@@ -9127,13 +8926,13 @@
       </p:sp>
       <p:graphicFrame>
         <p:nvGraphicFramePr>
-          <p:cNvPr id="3" name="chart-ic" descr=""/>
+          <p:cNvPr id="3" name="chart-e2e-vs-two-stage" descr=""/>
           <p:cNvGraphicFramePr/>
           <p:nvPr/>
         </p:nvGraphicFramePr>
         <p:xfrm>
           <a:off x="548640" y="1280160"/>
-          <a:ext cx="3749040" cy="3931920"/>
+          <a:ext cx="5760720" cy="4069080"/>
         </p:xfrm>
         <a:graphic xmlns:a="http://schemas.openxmlformats.org/drawingml/2006/main">
           <a:graphicData uri="http://schemas.openxmlformats.org/drawingml/2006/chart">
@@ -9141,36 +8940,20 @@
           </a:graphicData>
         </a:graphic>
       </p:graphicFrame>
-      <p:graphicFrame>
-        <p:nvGraphicFramePr>
-          <p:cNvPr id="4" name="chart-sr" descr=""/>
-          <p:cNvGraphicFramePr/>
-          <p:nvPr/>
-        </p:nvGraphicFramePr>
-        <p:xfrm>
-          <a:off x="4434840" y="1280160"/>
-          <a:ext cx="3749040" cy="3931920"/>
-        </p:xfrm>
-        <a:graphic xmlns:a="http://schemas.openxmlformats.org/drawingml/2006/main">
-          <a:graphicData uri="http://schemas.openxmlformats.org/drawingml/2006/chart">
-            <c:chart xmlns:c="http://schemas.openxmlformats.org/drawingml/2006/chart" r:id="rId2"/>
-          </a:graphicData>
-        </a:graphic>
-      </p:graphicFrame>
-      <p:sp>
-        <p:nvSpPr>
-          <p:cNvPr id="5" name="finding-card"/>
+      <p:sp>
+        <p:nvSpPr>
+          <p:cNvPr id="4" name="stat-da"/>
           <p:cNvSpPr/>
           <p:nvPr/>
         </p:nvSpPr>
         <p:spPr>
           <a:xfrm>
-            <a:off x="8412480" y="1325880"/>
-            <a:ext cx="3246120" cy="2423160"/>
+            <a:off x="6537960" y="1325880"/>
+            <a:ext cx="5120640" cy="1298448"/>
           </a:xfrm>
           <a:prstGeom prst="roundRect">
             <a:avLst>
-              <a:gd name="adj" fmla="val 3019"/>
+              <a:gd name="adj" fmla="val 5634"/>
             </a:avLst>
           </a:prstGeom>
           <a:solidFill>
@@ -9186,118 +8969,107 @@
       </p:sp>
       <p:sp>
         <p:nvSpPr>
-          <p:cNvPr id="6" name="Text 2"/>
+          <p:cNvPr id="5" name="Text 2"/>
           <p:cNvSpPr txBox="1"/>
           <p:nvPr/>
         </p:nvSpPr>
         <p:spPr>
           <a:xfrm>
-            <a:off x="8641080" y="1490472"/>
-            <a:ext cx="2788920" cy="365760"/>
-          </a:xfrm>
-          <a:prstGeom prst="rect">
-            <a:avLst/>
-          </a:prstGeom>
-          <a:noFill/>
-          <a:ln/>
-        </p:spPr>
-        <p:txBody>
-          <a:bodyPr wrap="square" lIns="0" tIns="0" rIns="0" bIns="0" rtlCol="0" anchor="t"/>
+            <a:off x="6720840" y="1453896"/>
+            <a:ext cx="1691640" cy="1051560"/>
+          </a:xfrm>
+          <a:prstGeom prst="rect">
+            <a:avLst/>
+          </a:prstGeom>
+          <a:noFill/>
+          <a:ln/>
+        </p:spPr>
+        <p:txBody>
+          <a:bodyPr wrap="square" lIns="0" tIns="0" rIns="0" bIns="0" rtlCol="0" anchor="ctr"/>
           <a:lstStyle/>
           <a:p>
             <a:pPr indent="0" marL="0">
               <a:buNone/>
             </a:pPr>
             <a:r>
-              <a:rPr lang="en-US" sz="1600" b="1" dirty="0">
+              <a:rPr lang="en-US" sz="2800" b="1" dirty="0">
+                <a:solidFill>
+                  <a:srgbClr val="EB6834"/>
+                </a:solidFill>
+                <a:latin typeface="Cambria" pitchFamily="34" charset="0"/>
+                <a:ea typeface="Cambria" pitchFamily="34" charset="-122"/>
+                <a:cs typeface="Cambria" pitchFamily="34" charset="-120"/>
+              </a:rPr>
+              <a:t>+8.6 pp</a:t>
+            </a:r>
+            <a:endParaRPr lang="en-US" sz="2800" dirty="0"/>
+          </a:p>
+        </p:txBody>
+      </p:sp>
+      <p:sp>
+        <p:nvSpPr>
+          <p:cNvPr id="6" name="Text 3"/>
+          <p:cNvSpPr txBox="1"/>
+          <p:nvPr/>
+        </p:nvSpPr>
+        <p:spPr>
+          <a:xfrm>
+            <a:off x="8503920" y="1453896"/>
+            <a:ext cx="3017520" cy="1051560"/>
+          </a:xfrm>
+          <a:prstGeom prst="rect">
+            <a:avLst/>
+          </a:prstGeom>
+          <a:noFill/>
+          <a:ln/>
+        </p:spPr>
+        <p:txBody>
+          <a:bodyPr wrap="square" lIns="0" tIns="0" rIns="0" bIns="0" rtlCol="0" anchor="ctr"/>
+          <a:lstStyle/>
+          <a:p>
+            <a:pPr indent="0" marL="0">
+              <a:buNone/>
+            </a:pPr>
+            <a:r>
+              <a:rPr lang="en-US" sz="1200" b="1" dirty="0">
                 <a:solidFill>
                   <a:schemeClr val="tx1"/>
                 </a:solidFill>
               </a:rPr>
-              <a:t>Higher IC ≠ better portfolio</a:t>
-            </a:r>
-            <a:endParaRPr lang="en-US" sz="1600" dirty="0"/>
-          </a:p>
-        </p:txBody>
-      </p:sp>
-      <p:sp>
-        <p:nvSpPr>
-          <p:cNvPr id="7" name="Text 3"/>
-          <p:cNvSpPr txBox="1"/>
-          <p:nvPr/>
-        </p:nvSpPr>
-        <p:spPr>
-          <a:xfrm>
-            <a:off x="8641080" y="1828800"/>
-            <a:ext cx="2834640" cy="1828800"/>
-          </a:xfrm>
-          <a:prstGeom prst="rect">
-            <a:avLst/>
-          </a:prstGeom>
-          <a:noFill/>
-          <a:ln/>
-        </p:spPr>
-        <p:txBody>
-          <a:bodyPr wrap="square" lIns="0" tIns="0" rIns="0" bIns="0" rtlCol="0" anchor="t"/>
-          <a:lstStyle/>
+              <a:t>Decision-aware PCA (ours)</a:t>
+            </a:r>
+            <a:endParaRPr lang="en-US" sz="1200" dirty="0"/>
+          </a:p>
           <a:p>
             <a:pPr indent="0" marL="0">
               <a:buNone/>
             </a:pPr>
             <a:r>
-              <a:rPr lang="en-US" sz="1300" dirty="0">
-                <a:solidFill>
-                  <a:schemeClr val="tx1"/>
-                </a:solidFill>
-              </a:rPr>
-              <a:t>Ridge-rank has the best rank IC (0.077), but Linear has the best long-only Sharpe (1.36): the paper's argument, in our data.</a:t>
-            </a:r>
-            <a:endParaRPr lang="en-US" sz="1300" dirty="0"/>
-          </a:p>
-          <a:p>
-            <a:pPr indent="0" marL="0">
-              <a:buNone/>
-            </a:pPr>
-            <a:r>
-              <a:rPr lang="en-US" sz="600" dirty="0">
-                <a:solidFill>
-                  <a:schemeClr val="tx1"/>
-                </a:solidFill>
-              </a:rPr>
-              <a:t> </a:t>
-            </a:r>
-            <a:endParaRPr lang="en-US" sz="1300" dirty="0"/>
-          </a:p>
-          <a:p>
-            <a:pPr indent="0" marL="0">
-              <a:buNone/>
-            </a:pPr>
-            <a:r>
-              <a:rPr lang="en-US" sz="1300" dirty="0">
+              <a:rPr lang="en-US" sz="1200" dirty="0">
                 <a:solidFill>
                   <a:srgbClr val="52514E"/>
                 </a:solidFill>
               </a:rPr>
-              <a:t>Unlike the paper, the networks do not beat Linear (NN3: 1.23).</a:t>
-            </a:r>
-            <a:endParaRPr lang="en-US" sz="1300" dirty="0"/>
-          </a:p>
-        </p:txBody>
-      </p:sp>
-      <p:sp>
-        <p:nvSpPr>
-          <p:cNvPr id="8" name="microcap-card"/>
+              <a:t>PCA20-Linear: 21.8% → 30.4% a year when the loadings learn from the portfolio (t = 5.0)</a:t>
+            </a:r>
+            <a:endParaRPr lang="en-US" sz="1200" dirty="0"/>
+          </a:p>
+        </p:txBody>
+      </p:sp>
+      <p:sp>
+        <p:nvSpPr>
+          <p:cNvPr id="7" name="stat-costs"/>
           <p:cNvSpPr/>
           <p:nvPr/>
         </p:nvSpPr>
         <p:spPr>
           <a:xfrm>
-            <a:off x="8412480" y="3931920"/>
-            <a:ext cx="3246120" cy="1280160"/>
+            <a:off x="6537960" y="2715768"/>
+            <a:ext cx="5120640" cy="1298448"/>
           </a:xfrm>
           <a:prstGeom prst="roundRect">
             <a:avLst>
-              <a:gd name="adj" fmla="val 5714"/>
+              <a:gd name="adj" fmla="val 5634"/>
             </a:avLst>
           </a:prstGeom>
           <a:solidFill>
@@ -9313,90 +9085,107 @@
       </p:sp>
       <p:sp>
         <p:nvSpPr>
-          <p:cNvPr id="9" name="Text 5"/>
+          <p:cNvPr id="8" name="Text 5"/>
           <p:cNvSpPr txBox="1"/>
           <p:nvPr/>
         </p:nvSpPr>
         <p:spPr>
           <a:xfrm>
-            <a:off x="8641080" y="4096512"/>
-            <a:ext cx="2788920" cy="365760"/>
-          </a:xfrm>
-          <a:prstGeom prst="rect">
-            <a:avLst/>
-          </a:prstGeom>
-          <a:noFill/>
-          <a:ln/>
-        </p:spPr>
-        <p:txBody>
-          <a:bodyPr wrap="square" lIns="0" tIns="0" rIns="0" bIns="0" rtlCol="0" anchor="t"/>
+            <a:off x="6720840" y="2843784"/>
+            <a:ext cx="1691640" cy="1051560"/>
+          </a:xfrm>
+          <a:prstGeom prst="rect">
+            <a:avLst/>
+          </a:prstGeom>
+          <a:noFill/>
+          <a:ln/>
+        </p:spPr>
+        <p:txBody>
+          <a:bodyPr wrap="square" lIns="0" tIns="0" rIns="0" bIns="0" rtlCol="0" anchor="ctr"/>
           <a:lstStyle/>
           <a:p>
             <a:pPr indent="0" marL="0">
               <a:buNone/>
             </a:pPr>
             <a:r>
-              <a:rPr lang="en-US" sz="1600" b="1" dirty="0">
+              <a:rPr lang="en-US" sz="2800" b="1" dirty="0">
+                <a:solidFill>
+                  <a:srgbClr val="EB6834"/>
+                </a:solidFill>
+                <a:latin typeface="Cambria" pitchFamily="34" charset="0"/>
+                <a:ea typeface="Cambria" pitchFamily="34" charset="-122"/>
+                <a:cs typeface="Cambria" pitchFamily="34" charset="-120"/>
+              </a:rPr>
+              <a:t>7%</a:t>
+            </a:r>
+            <a:endParaRPr lang="en-US" sz="2800" dirty="0"/>
+          </a:p>
+        </p:txBody>
+      </p:sp>
+      <p:sp>
+        <p:nvSpPr>
+          <p:cNvPr id="9" name="Text 6"/>
+          <p:cNvSpPr txBox="1"/>
+          <p:nvPr/>
+        </p:nvSpPr>
+        <p:spPr>
+          <a:xfrm>
+            <a:off x="8503920" y="2843784"/>
+            <a:ext cx="3017520" cy="1051560"/>
+          </a:xfrm>
+          <a:prstGeom prst="rect">
+            <a:avLst/>
+          </a:prstGeom>
+          <a:noFill/>
+          <a:ln/>
+        </p:spPr>
+        <p:txBody>
+          <a:bodyPr wrap="square" lIns="0" tIns="0" rIns="0" bIns="0" rtlCol="0" anchor="ctr"/>
+          <a:lstStyle/>
+          <a:p>
+            <a:pPr indent="0" marL="0">
+              <a:buNone/>
+            </a:pPr>
+            <a:r>
+              <a:rPr lang="en-US" sz="1200" b="1" dirty="0">
                 <a:solidFill>
                   <a:schemeClr val="tx1"/>
                 </a:solidFill>
               </a:rPr>
-              <a:t>Excluding microcaps</a:t>
-            </a:r>
-            <a:endParaRPr lang="en-US" sz="1600" dirty="0"/>
-          </a:p>
-        </p:txBody>
-      </p:sp>
-      <p:sp>
-        <p:nvSpPr>
-          <p:cNvPr id="10" name="Text 6"/>
-          <p:cNvSpPr txBox="1"/>
-          <p:nvPr/>
-        </p:nvSpPr>
-        <p:spPr>
-          <a:xfrm>
-            <a:off x="8641080" y="4370832"/>
-            <a:ext cx="2834640" cy="777240"/>
-          </a:xfrm>
-          <a:prstGeom prst="rect">
-            <a:avLst/>
-          </a:prstGeom>
-          <a:noFill/>
-          <a:ln/>
-        </p:spPr>
-        <p:txBody>
-          <a:bodyPr wrap="square" lIns="0" tIns="0" rIns="0" bIns="0" rtlCol="0" anchor="t"/>
-          <a:lstStyle/>
+              <a:t>Costs, 20 bps: daily turnover of E2E</a:t>
+            </a:r>
+            <a:endParaRPr lang="en-US" sz="1200" dirty="0"/>
+          </a:p>
           <a:p>
             <a:pPr indent="0" marL="0">
               <a:buNone/>
             </a:pPr>
             <a:r>
-              <a:rPr lang="en-US" sz="1300" dirty="0">
-                <a:solidFill>
-                  <a:schemeClr val="tx1"/>
-                </a:solidFill>
-              </a:rPr>
-              <a:t>Our Linear: 22.8% a year (SR 1.03); the paper reports 28.0% (1.44)</a:t>
-            </a:r>
-            <a:endParaRPr lang="en-US" sz="1300" dirty="0"/>
-          </a:p>
-        </p:txBody>
-      </p:sp>
-      <p:sp>
-        <p:nvSpPr>
-          <p:cNvPr id="11" name="pending-box"/>
+              <a:rPr lang="en-US" sz="1200" dirty="0">
+                <a:solidFill>
+                  <a:srgbClr val="52514E"/>
+                </a:solidFill>
+              </a:rPr>
+              <a:t>vs 28% for the MSE top decile. Net return 24.7% vs 15.2% (MSE-Top) and 23.2% (tuned MSE-Opt, t = 1.2)</a:t>
+            </a:r>
+            <a:endParaRPr lang="en-US" sz="1200" dirty="0"/>
+          </a:p>
+        </p:txBody>
+      </p:sp>
+      <p:sp>
+        <p:nvSpPr>
+          <p:cNvPr id="10" name="stat-meansd"/>
           <p:cNvSpPr/>
           <p:nvPr/>
         </p:nvSpPr>
         <p:spPr>
           <a:xfrm>
-            <a:off x="548640" y="5440680"/>
-            <a:ext cx="11109960" cy="731520"/>
+            <a:off x="6537960" y="4105656"/>
+            <a:ext cx="5120640" cy="1298448"/>
           </a:xfrm>
           <a:prstGeom prst="roundRect">
             <a:avLst>
-              <a:gd name="adj" fmla="val 7500"/>
+              <a:gd name="adj" fmla="val 5634"/>
             </a:avLst>
           </a:prstGeom>
           <a:solidFill>
@@ -9412,14 +9201,14 @@
       </p:sp>
       <p:sp>
         <p:nvSpPr>
-          <p:cNvPr id="12" name="Text 8"/>
+          <p:cNvPr id="11" name="Text 8"/>
           <p:cNvSpPr txBox="1"/>
           <p:nvPr/>
         </p:nvSpPr>
         <p:spPr>
           <a:xfrm>
-            <a:off x="777240" y="5440680"/>
-            <a:ext cx="10698480" cy="731520"/>
+            <a:off x="6720840" y="4233672"/>
+            <a:ext cx="1691640" cy="1051560"/>
           </a:xfrm>
           <a:prstGeom prst="rect">
             <a:avLst/>
@@ -9435,25 +9224,141 @@
               <a:buNone/>
             </a:pPr>
             <a:r>
-              <a:rPr lang="en-US" sz="1400" b="1" dirty="0">
+              <a:rPr lang="en-US" sz="2800" b="1" dirty="0">
+                <a:solidFill>
+                  <a:srgbClr val="EB6834"/>
+                </a:solidFill>
+                <a:latin typeface="Cambria" pitchFamily="34" charset="0"/>
+                <a:ea typeface="Cambria" pitchFamily="34" charset="-122"/>
+                <a:cs typeface="Cambria" pitchFamily="34" charset="-120"/>
+              </a:rPr>
+              <a:t>1.36</a:t>
+            </a:r>
+            <a:endParaRPr lang="en-US" sz="2800" dirty="0"/>
+          </a:p>
+        </p:txBody>
+      </p:sp>
+      <p:sp>
+        <p:nvSpPr>
+          <p:cNvPr id="12" name="Text 9"/>
+          <p:cNvSpPr txBox="1"/>
+          <p:nvPr/>
+        </p:nvSpPr>
+        <p:spPr>
+          <a:xfrm>
+            <a:off x="8503920" y="4233672"/>
+            <a:ext cx="3017520" cy="1051560"/>
+          </a:xfrm>
+          <a:prstGeom prst="rect">
+            <a:avLst/>
+          </a:prstGeom>
+          <a:noFill/>
+          <a:ln/>
+        </p:spPr>
+        <p:txBody>
+          <a:bodyPr wrap="square" lIns="0" tIns="0" rIns="0" bIns="0" rtlCol="0" anchor="ctr"/>
+          <a:lstStyle/>
+          <a:p>
+            <a:pPr indent="0" marL="0">
+              <a:buNone/>
+            </a:pPr>
+            <a:r>
+              <a:rPr lang="en-US" sz="1200" b="1" dirty="0">
+                <a:solidFill>
+                  <a:schemeClr val="tx1"/>
+                </a:solidFill>
+              </a:rPr>
+              <a:t>Mean–SD, η = 1: Sharpe of E2E</a:t>
+            </a:r>
+            <a:endParaRPr lang="en-US" sz="1200" dirty="0"/>
+          </a:p>
+          <a:p>
+            <a:pPr indent="0" marL="0">
+              <a:buNone/>
+            </a:pPr>
+            <a:r>
+              <a:rPr lang="en-US" sz="1200" dirty="0">
+                <a:solidFill>
+                  <a:srgbClr val="52514E"/>
+                </a:solidFill>
+              </a:rPr>
+              <a:t>vs 1.28 for MSE-Opt; volatility 22.1% vs 23.0% (difference t = 0.3)</a:t>
+            </a:r>
+            <a:endParaRPr lang="en-US" sz="1200" dirty="0"/>
+          </a:p>
+        </p:txBody>
+      </p:sp>
+      <p:sp>
+        <p:nvSpPr>
+          <p:cNvPr id="13" name="finding-box"/>
+          <p:cNvSpPr/>
+          <p:nvPr/>
+        </p:nvSpPr>
+        <p:spPr>
+          <a:xfrm>
+            <a:off x="548640" y="5532120"/>
+            <a:ext cx="11109960" cy="658368"/>
+          </a:xfrm>
+          <a:prstGeom prst="roundRect">
+            <a:avLst>
+              <a:gd name="adj" fmla="val 8333"/>
+            </a:avLst>
+          </a:prstGeom>
+          <a:solidFill>
+            <a:srgbClr val="E2EFF0"/>
+          </a:solidFill>
+          <a:ln w="12700">
+            <a:solidFill>
+              <a:srgbClr val="E2EFF0"/>
+            </a:solidFill>
+            <a:prstDash val="solid"/>
+          </a:ln>
+        </p:spPr>
+      </p:sp>
+      <p:sp>
+        <p:nvSpPr>
+          <p:cNvPr id="14" name="Text 11"/>
+          <p:cNvSpPr txBox="1"/>
+          <p:nvPr/>
+        </p:nvSpPr>
+        <p:spPr>
+          <a:xfrm>
+            <a:off x="777240" y="5532120"/>
+            <a:ext cx="10698480" cy="658368"/>
+          </a:xfrm>
+          <a:prstGeom prst="rect">
+            <a:avLst/>
+          </a:prstGeom>
+          <a:noFill/>
+          <a:ln/>
+        </p:spPr>
+        <p:txBody>
+          <a:bodyPr wrap="square" lIns="0" tIns="0" rIns="0" bIns="0" rtlCol="0" anchor="ctr"/>
+          <a:lstStyle/>
+          <a:p>
+            <a:pPr indent="0" marL="0">
+              <a:buNone/>
+            </a:pPr>
+            <a:r>
+              <a:rPr lang="en-US" sz="1300" b="1" dirty="0">
                 <a:solidFill>
                   <a:schemeClr val="tx2"/>
                 </a:solidFill>
               </a:rPr>
-              <a:t>To be added when training finishes: </a:t>
+              <a:t>Accuracy ≠ decision quality: </a:t>
             </a:r>
             <a:pPr indent="0" marL="0">
               <a:buNone/>
             </a:pPr>
             <a:r>
-              <a:rPr lang="en-US" sz="1400" dirty="0">
+              <a:rPr lang="en-US" sz="1300" dirty="0">
                 <a:solidFill>
                   <a:schemeClr val="tx1"/>
                 </a:solidFill>
               </a:rPr>
-              <a:t>E2E versions (paper models and ours), transaction costs 0–40 bps, risk aversion, decision-aware PCA, GMM experts.</a:t>
-            </a:r>
-            <a:endParaRPr lang="en-US" sz="1400" dirty="0"/>
+              <a:t>among two-stage models Ridge-rank has the best rank IC (0.077) but Linear the best long-only Sharpe (1.36).</a:t>
+            </a:r>
+            <a:endParaRPr lang="en-US" sz="1300" dirty="0"/>
           </a:p>
         </p:txBody>
       </p:sp>

</xml_diff>